<commit_message>
Remove video script from the repo (notes stripped from slides; README tidy)
</commit_message>
<xml_diff>
--- a/deliverables/Diagnostic_Momentum_Slides.pptx
+++ b/deliverables/Diagnostic_Momentum_Slides.pptx
@@ -1021,11 +1021,7 @@
         <p:txBody>
           <a:bodyPr/>
           <a:lstStyle/>
-          <a:p>
-            <a:r>
-              <a:t>[0:00–0:15] Hi, I'm Lakshita Singh. For Topic 2, clinical decision making and pattern recognition, I asked one question: do AI medical coders copy a wrong diagnosis forward, and put it on the claim?</a:t>
-            </a:r>
-          </a:p>
+          <a:p/>
         </p:txBody>
       </p:sp>
       <p:sp>
@@ -1091,11 +1087,7 @@
         <p:txBody>
           <a:bodyPr/>
           <a:lstStyle/>
-          <a:p>
-            <a:r>
-              <a:t>[3:00–4:15] SWITCH TO THE DEMO APP. Let me show it. The Results tab has the headline numbers. Now patient 1992, copied three times: here is the fake, morbid obesity, in the problem list. The AI coder codes it, and it's tagged planted fake. I switch to the ruled-out version: the latest note says it was excluded, and the coder still codes it. Now the evidence auditor: it drops the fake, keeps every true diagnosis with a quoted sentence as proof, and accuracy goes to one point zero. SWITCH BACK TO SLIDES.</a:t>
-            </a:r>
-          </a:p>
+          <a:p/>
         </p:txBody>
       </p:sp>
       <p:sp>
@@ -1161,11 +1153,7 @@
         <p:txBody>
           <a:bodyPr/>
           <a:lstStyle/>
-          <a:p>
-            <a:r>
-              <a:t>[4:15–4:35] For Cotiviti, the opportunities are evidence-cited chart review at scale and cheap, verifiable model testing. The threats are automated overpayment, and false confidence in prompt-level fixes.</a:t>
-            </a:r>
-          </a:p>
+          <a:p/>
         </p:txBody>
       </p:sp>
       <p:sp>
@@ -1231,11 +1219,7 @@
         <p:txBody>
           <a:bodyPr/>
           <a:lstStyle/>
-          <a:p>
-            <a:r>
-              <a:t>[4:35–4:55] So, three recommendations: adopt an evidence-first standard for AI coding; make planted-error stress tests a release gate for every model; and lead on documentation-evidence standards in the coding arms race. The whole study cost one dollar fifteen. Thank you.</a:t>
-            </a:r>
-          </a:p>
+          <a:p/>
         </p:txBody>
       </p:sp>
       <p:sp>
@@ -1301,11 +1285,7 @@
         <p:txBody>
           <a:bodyPr/>
           <a:lstStyle/>
-          <a:p>
-            <a:r>
-              <a:t>[0:15–0:40] Every visit note carries an Active Problem List that is copied from the previous note. Doctors call the resulting failure diagnostic momentum: once a diagnosis is written down, it gets repeated without being re-checked. Today, AI coders read these charts and assign the ICD-10 codes that claims are paid on. If the AI trusts the problem list, it codes the error. The highlighted line here is one I planted.</a:t>
-            </a:r>
-          </a:p>
+          <a:p/>
         </p:txBody>
       </p:sp>
       <p:sp>
@@ -1371,11 +1351,7 @@
         <p:txBody>
           <a:bodyPr/>
           <a:lstStyle/>
-          <a:p>
-            <a:r>
-              <a:t>[0:40–1:00] This matters now. After adopting AI scribes, hospitals billed twelve to twenty points more visits at the top levels, and payers are answering with their own AI: a coding arms race. CMS started AI-assisted prior authorization this year. And research shows language models accept false medical evidence at face value.</a:t>
-            </a:r>
-          </a:p>
+          <a:p/>
         </p:txBody>
       </p:sp>
       <p:sp>
@@ -1441,11 +1417,7 @@
         <p:txBody>
           <a:bodyPr/>
           <a:lstStyle/>
-          <a:p>
-            <a:r>
-              <a:t>[1:00–1:20] Real charts can't tell us whether a copied diagnosis is wrong. Synthetic Hospital, released by Carnegie Mellon this month, can: 1,268 synthetic patients, charts physicians can't tell from real ones, and a verified answer key. Its authors say it doesn't yet simulate documentation errors, so that's the layer I added.</a:t>
-            </a:r>
-          </a:p>
+          <a:p/>
         </p:txBody>
       </p:sp>
       <p:sp>
@@ -1511,11 +1483,7 @@
         <p:txBody>
           <a:bodyPr/>
           <a:lstStyle/>
-          <a:p>
-            <a:r>
-              <a:t>[1:20–1:45] For fifty patients, I picked one believable wrong diagnosis, a tempting wrong exam answer that matches at least two findings in the chart, and planted it as a single problem-list line. The AI coder only sees the chart. The answer key, and which diagnosis is fake, go straight to the scorer.</a:t>
-            </a:r>
-          </a:p>
+          <a:p/>
         </p:txBody>
       </p:sp>
       <p:sp>
@@ -1581,11 +1549,7 @@
         <p:txBody>
           <a:bodyPr/>
           <a:lstStyle/>
-          <a:p>
-            <a:r>
-              <a:t>[1:45–2:00] Each patient appears in five versions: clean, copied once, copied three times, three times plus a note saying it was ruled out, and planted early then dropped. Only that one line changes.</a:t>
-            </a:r>
-          </a:p>
+          <a:p/>
         </p:txBody>
       </p:sp>
       <p:sp>
@@ -1651,11 +1615,7 @@
         <p:txBody>
           <a:bodyPr/>
           <a:lstStyle/>
-          <a:p>
-            <a:r>
-              <a:t>[2:00–2:20] Result one. On clean charts the AI almost never codes the fake: two percent. Copy it in once, and it codes it ninety percent of the time. Even when the chart explicitly says it was ruled out: forty-eight percent.</a:t>
-            </a:r>
-          </a:p>
+          <a:p/>
         </p:txBody>
       </p:sp>
       <p:sp>
@@ -1721,11 +1681,7 @@
         <p:txBody>
           <a:bodyPr/>
           <a:lstStyle/>
-          <a:p>
-            <a:r>
-              <a:t>[2:20–2:45] Can we fix it? A warning in the prompt only brings ninety-two percent down to fifty-eight. A design change works much better: an evidence auditor, a second step that keeps a code only if it can quote evidence from the visit notes. That cuts it to twenty percent, with accuracy on the true diagnoses essentially unchanged, for about a fifth of a cent per chart.</a:t>
-            </a:r>
-          </a:p>
+          <a:p/>
         </p:txBody>
       </p:sp>
       <p:sp>
@@ -1791,11 +1747,7 @@
         <p:txBody>
           <a:bodyPr/>
           <a:lstStyle/>
-          <a:p>
-            <a:r>
-              <a:t>[2:45–3:00] And it isn't one model's quirk. Two Gemini models show the same effect at lower rates. Interestingly, they respect the ruled-out note, which gpt-oss ignores half the time. So every AI tool needs its own stress test.</a:t>
-            </a:r>
-          </a:p>
+          <a:p/>
         </p:txBody>
       </p:sp>
       <p:sp>

</xml_diff>